<commit_message>
project recap - doc updates, new experiment of fractal synthetic pretrained models for learned semanthic not using real world data
</commit_message>
<xml_diff>
--- a/docs/Viva_Presentation.pptx
+++ b/docs/Viva_Presentation.pptx
@@ -17,6 +17,8 @@
     <p:sldId id="265" r:id="rId11"/>
     <p:sldId id="266" r:id="rId12"/>
     <p:sldId id="267" r:id="rId13"/>
+    <p:sldId id="276" r:id="rId27"/>
+    <p:sldId id="277" r:id="rId28"/>
     <p:sldId id="268" r:id="rId14"/>
     <p:sldId id="269" r:id="rId15"/>
     <p:sldId id="270" r:id="rId16"/>
@@ -2716,7 +2718,7 @@
                 <a:ea typeface="Calibri" pitchFamily="34" charset="-122"/>
                 <a:cs typeface="Calibri" pitchFamily="34" charset="-120"/>
               </a:rPr>
-              <a:t>Final project defense · 8 encoders · 9 findings · 11 falsified explanations · 20 minutes</a:t>
+              <a:t>Final project defense · 11 encoders · 9 findings · 11 falsified explanations · 20 minutes</a:t>
             </a:r>
             <a:endParaRPr lang="en-US" sz="1200" dirty="0"/>
           </a:p>
@@ -4973,6 +4975,10 @@
           </a:solidFill>
           <a:ln/>
         </p:spPr>
+        <p:txBody>
+          <a:bodyPr/>
+          <a:p/>
+        </p:txBody>
       </p:sp>
       <p:sp>
         <p:nvSpPr>
@@ -5048,6 +5054,10 @@
           </a:solidFill>
           <a:ln/>
         </p:spPr>
+        <p:txBody>
+          <a:bodyPr/>
+          <a:p/>
+        </p:txBody>
       </p:sp>
       <p:sp>
         <p:nvSpPr>
@@ -5123,6 +5133,10 @@
           </a:solidFill>
           <a:ln/>
         </p:spPr>
+        <p:txBody>
+          <a:bodyPr/>
+          <a:p/>
+        </p:txBody>
       </p:sp>
       <p:sp>
         <p:nvSpPr>
@@ -5255,6 +5269,543 @@
 </file>
 
 <file path=ppt/slides/slide13.xml><?xml version="1.0" encoding="utf-8"?>
+<p:sld xmlns:a="http://schemas.openxmlformats.org/drawingml/2006/main" xmlns:p="http://schemas.openxmlformats.org/presentationml/2006/main" xmlns:r="http://schemas.openxmlformats.org/officeDocument/2006/relationships">
+  <p:cSld>
+    <p:spTree>
+      <p:nvGrpSpPr>
+        <p:cNvPr id="1" name=""/>
+        <p:cNvGrpSpPr/>
+        <p:nvPr/>
+      </p:nvGrpSpPr>
+      <p:grpSpPr/>
+      <p:sp>
+        <p:nvSpPr>
+          <p:cNvPr id="2" name="TextBox 1"/>
+          <p:cNvSpPr txBox="1"/>
+          <p:nvPr/>
+        </p:nvSpPr>
+        <p:spPr>
+          <a:xfrm>
+            <a:off x="548640" y="274320"/>
+            <a:ext cx="10058400" cy="365760"/>
+          </a:xfrm>
+          <a:prstGeom prst="rect">
+            <a:avLst/>
+          </a:prstGeom>
+          <a:noFill/>
+        </p:spPr>
+        <p:txBody>
+          <a:bodyPr wrap="none">
+            <a:spAutoFit/>
+          </a:bodyPr>
+          <a:lstStyle/>
+          <a:p>
+            <a:r>
+              <a:rPr sz="1100" b="1">
+                <a:solidFill>
+                  <a:srgbClr val="5A6472"/>
+                </a:solidFill>
+                <a:latin typeface="Calibri"/>
+              </a:rPr>
+              <a:t>FINDINGS · SCALE</a:t>
+            </a:r>
+          </a:p>
+        </p:txBody>
+      </p:sp>
+      <p:sp>
+        <p:nvSpPr>
+          <p:cNvPr id="3" name="TextBox 2"/>
+          <p:cNvSpPr txBox="1"/>
+          <p:nvPr/>
+        </p:nvSpPr>
+        <p:spPr>
+          <a:xfrm>
+            <a:off x="548640" y="548640"/>
+            <a:ext cx="11064240" cy="685800"/>
+          </a:xfrm>
+          <a:prstGeom prst="rect">
+            <a:avLst/>
+          </a:prstGeom>
+          <a:noFill/>
+        </p:spPr>
+        <p:txBody>
+          <a:bodyPr wrap="square">
+            <a:spAutoFit/>
+          </a:bodyPr>
+          <a:lstStyle/>
+          <a:p>
+            <a:r>
+              <a:rPr sz="2300" b="1">
+                <a:solidFill>
+                  <a:srgbClr val="1E2761"/>
+                </a:solidFill>
+                <a:latin typeface="Cambria"/>
+              </a:rPr>
+              <a:t>Does cross-modal alignment strengthen with capacity? Pre-registered — and no.</a:t>
+            </a:r>
+          </a:p>
+        </p:txBody>
+      </p:sp>
+      <p:pic>
+        <p:nvPicPr>
+          <p:cNvPr id="4" name="Picture 3" descr="ladder.png"/>
+          <p:cNvPicPr>
+            <a:picLocks noChangeAspect="1"/>
+          </p:cNvPicPr>
+          <p:nvPr/>
+        </p:nvPicPr>
+        <p:blipFill>
+          <a:blip r:embed="rId2"/>
+          <a:stretch>
+            <a:fillRect/>
+          </a:stretch>
+        </p:blipFill>
+        <p:spPr>
+          <a:xfrm>
+            <a:off x="548640" y="1417320"/>
+            <a:ext cx="6534033" cy="4160520"/>
+          </a:xfrm>
+          <a:prstGeom prst="rect">
+            <a:avLst/>
+          </a:prstGeom>
+        </p:spPr>
+      </p:pic>
+      <p:sp>
+        <p:nvSpPr>
+          <p:cNvPr id="5" name="TextBox 4"/>
+          <p:cNvSpPr txBox="1"/>
+          <p:nvPr/>
+        </p:nvSpPr>
+        <p:spPr>
+          <a:xfrm>
+            <a:off x="8595360" y="1600200"/>
+            <a:ext cx="3383280" cy="4023360"/>
+          </a:xfrm>
+          <a:prstGeom prst="rect">
+            <a:avLst/>
+          </a:prstGeom>
+          <a:noFill/>
+        </p:spPr>
+        <p:txBody>
+          <a:bodyPr wrap="square">
+            <a:spAutoFit/>
+          </a:bodyPr>
+          <a:lstStyle/>
+          <a:p>
+            <a:pPr>
+              <a:spcAft>
+                <a:spcPts val="500"/>
+              </a:spcAft>
+            </a:pPr>
+            <a:r>
+              <a:rPr sz="1300" b="0">
+                <a:solidFill>
+                  <a:srgbClr val="1A1A2E"/>
+                </a:solidFill>
+                <a:latin typeface="Calibri"/>
+              </a:rPr>
+              <a:t>Huh et al. (2024) show alignment rising with scale to 70B. Tested here on</a:t>
+            </a:r>
+          </a:p>
+          <a:p>
+            <a:pPr>
+              <a:spcAft>
+                <a:spcPts val="500"/>
+              </a:spcAft>
+            </a:pPr>
+            <a:r>
+              <a:rPr sz="1300" b="0">
+                <a:solidFill>
+                  <a:srgbClr val="1A1A2E"/>
+                </a:solidFill>
+                <a:latin typeface="Calibri"/>
+              </a:rPr>
+              <a:t>both modalities, matched pooling, raw geometry — capacity the only variable.</a:t>
+            </a:r>
+          </a:p>
+          <a:p>
+            <a:pPr>
+              <a:spcAft>
+                <a:spcPts val="500"/>
+              </a:spcAft>
+            </a:pPr>
+            <a:r>
+              <a:rPr sz="1300" b="0">
+                <a:solidFill>
+                  <a:srgbClr val="1A1A2E"/>
+                </a:solidFill>
+                <a:latin typeface="Calibri"/>
+              </a:rPr>
+              <a:t/>
+            </a:r>
+          </a:p>
+          <a:p>
+            <a:pPr>
+              <a:spcAft>
+                <a:spcPts val="500"/>
+              </a:spcAft>
+            </a:pPr>
+            <a:r>
+              <a:rPr sz="1300" b="0">
+                <a:solidFill>
+                  <a:srgbClr val="1A1A2E"/>
+                </a:solidFill>
+                <a:latin typeface="Calibri"/>
+              </a:rPr>
+              <a:t>DINOv2 image:  0.381 → 0.381 → 0.418 → 0.339 at giant (1.14B)</a:t>
+            </a:r>
+          </a:p>
+          <a:p>
+            <a:pPr>
+              <a:spcAft>
+                <a:spcPts val="500"/>
+              </a:spcAft>
+            </a:pPr>
+            <a:r>
+              <a:rPr sz="1300" b="0">
+                <a:solidFill>
+                  <a:srgbClr val="1A1A2E"/>
+                </a:solidFill>
+                <a:latin typeface="Calibri"/>
+              </a:rPr>
+              <a:t>Contrastive text:  0.320 → 0.352 → 0.307 at Qwen-4B (7× bge-m3)</a:t>
+            </a:r>
+          </a:p>
+          <a:p>
+            <a:pPr>
+              <a:spcAft>
+                <a:spcPts val="500"/>
+              </a:spcAft>
+            </a:pPr>
+            <a:r>
+              <a:rPr sz="1300" b="0">
+                <a:solidFill>
+                  <a:srgbClr val="1A1A2E"/>
+                </a:solidFill>
+                <a:latin typeface="Calibri"/>
+              </a:rPr>
+              <a:t/>
+            </a:r>
+          </a:p>
+          <a:p>
+            <a:pPr>
+              <a:spcAft>
+                <a:spcPts val="500"/>
+              </a:spcAft>
+            </a:pPr>
+            <a:r>
+              <a:rPr sz="1300" b="1">
+                <a:solidFill>
+                  <a:srgbClr val="B02418"/>
+                </a:solidFill>
+                <a:latin typeface="Calibri"/>
+              </a:rPr>
+              <a:t>Both ladders rise then FALL.</a:t>
+            </a:r>
+          </a:p>
+          <a:p>
+            <a:pPr>
+              <a:spcAft>
+                <a:spcPts val="500"/>
+              </a:spcAft>
+            </a:pPr>
+            <a:r>
+              <a:rPr sz="1300" b="1">
+                <a:solidFill>
+                  <a:srgbClr val="B02418"/>
+                </a:solidFill>
+                <a:latin typeface="Calibri"/>
+              </a:rPr>
+              <a:t>P2 and P3 pre-registered, both FALSIFIED.</a:t>
+            </a:r>
+          </a:p>
+        </p:txBody>
+      </p:sp>
+      <p:sp>
+        <p:nvSpPr>
+          <p:cNvPr id="6" name="TextBox 5"/>
+          <p:cNvSpPr txBox="1"/>
+          <p:nvPr/>
+        </p:nvSpPr>
+        <p:spPr>
+          <a:xfrm>
+            <a:off x="548640" y="5852160"/>
+            <a:ext cx="11430000" cy="868680"/>
+          </a:xfrm>
+          <a:prstGeom prst="rect">
+            <a:avLst/>
+          </a:prstGeom>
+          <a:noFill/>
+        </p:spPr>
+        <p:txBody>
+          <a:bodyPr wrap="square">
+            <a:spAutoFit/>
+          </a:bodyPr>
+          <a:lstStyle/>
+          <a:p>
+            <a:pPr>
+              <a:spcAft>
+                <a:spcPts val="500"/>
+              </a:spcAft>
+            </a:pPr>
+            <a:r>
+              <a:rPr sz="1200" b="0">
+                <a:solidFill>
+                  <a:srgbClr val="5A6472"/>
+                </a:solidFill>
+                <a:latin typeface="Calibri"/>
+              </a:rPr>
+              <a:t>Within-modality, contrastive text encoders agree with each other at 0.76–0.86 — the highest pairs in the 55-pair matrix — while cross-modal agreement stays 0.19–0.35 and does not rise with scale. A measured answer to the scale caveat, not a concession: the 70B regime is a different one.</a:t>
+            </a:r>
+          </a:p>
+        </p:txBody>
+      </p:sp>
+    </p:spTree>
+  </p:cSld>
+  <p:clrMapOvr>
+    <a:masterClrMapping/>
+  </p:clrMapOvr>
+</p:sld>
+</file>
+
+<file path=ppt/slides/slide14.xml><?xml version="1.0" encoding="utf-8"?>
+<p:sld xmlns:a="http://schemas.openxmlformats.org/drawingml/2006/main" xmlns:p="http://schemas.openxmlformats.org/presentationml/2006/main" xmlns:r="http://schemas.openxmlformats.org/officeDocument/2006/relationships">
+  <p:cSld>
+    <p:spTree>
+      <p:nvGrpSpPr>
+        <p:cNvPr id="1" name=""/>
+        <p:cNvGrpSpPr/>
+        <p:nvPr/>
+      </p:nvGrpSpPr>
+      <p:grpSpPr/>
+      <p:sp>
+        <p:nvSpPr>
+          <p:cNvPr id="2" name="TextBox 1"/>
+          <p:cNvSpPr txBox="1"/>
+          <p:nvPr/>
+        </p:nvSpPr>
+        <p:spPr>
+          <a:xfrm>
+            <a:off x="548640" y="274320"/>
+            <a:ext cx="10058400" cy="365760"/>
+          </a:xfrm>
+          <a:prstGeom prst="rect">
+            <a:avLst/>
+          </a:prstGeom>
+          <a:noFill/>
+        </p:spPr>
+        <p:txBody>
+          <a:bodyPr wrap="none">
+            <a:spAutoFit/>
+          </a:bodyPr>
+          <a:lstStyle/>
+          <a:p>
+            <a:r>
+              <a:rPr sz="1100" b="1">
+                <a:solidFill>
+                  <a:srgbClr val="5A6472"/>
+                </a:solidFill>
+                <a:latin typeface="Calibri"/>
+              </a:rPr>
+              <a:t>FINDINGS · SCALE — read with care</a:t>
+            </a:r>
+          </a:p>
+        </p:txBody>
+      </p:sp>
+      <p:sp>
+        <p:nvSpPr>
+          <p:cNvPr id="3" name="TextBox 2"/>
+          <p:cNvSpPr txBox="1"/>
+          <p:nvPr/>
+        </p:nvSpPr>
+        <p:spPr>
+          <a:xfrm>
+            <a:off x="548640" y="548640"/>
+            <a:ext cx="11064240" cy="685800"/>
+          </a:xfrm>
+          <a:prstGeom prst="rect">
+            <a:avLst/>
+          </a:prstGeom>
+          <a:noFill/>
+        </p:spPr>
+        <p:txBody>
+          <a:bodyPr wrap="square">
+            <a:spAutoFit/>
+          </a:bodyPr>
+          <a:lstStyle/>
+          <a:p>
+            <a:r>
+              <a:rPr sz="2300" b="1">
+                <a:solidFill>
+                  <a:srgbClr val="1E2761"/>
+                </a:solidFill>
+                <a:latin typeface="Cambria"/>
+              </a:rPr>
+              <a:t>Why ρ is the clean test, and the transfer numbers are not</a:t>
+            </a:r>
+          </a:p>
+        </p:txBody>
+      </p:sp>
+      <p:sp>
+        <p:nvSpPr>
+          <p:cNvPr id="4" name="TextBox 3"/>
+          <p:cNvSpPr txBox="1"/>
+          <p:nvPr/>
+        </p:nvSpPr>
+        <p:spPr>
+          <a:xfrm>
+            <a:off x="548640" y="1463040"/>
+            <a:ext cx="11430000" cy="4937760"/>
+          </a:xfrm>
+          <a:prstGeom prst="rect">
+            <a:avLst/>
+          </a:prstGeom>
+          <a:noFill/>
+        </p:spPr>
+        <p:txBody>
+          <a:bodyPr wrap="square">
+            <a:spAutoFit/>
+          </a:bodyPr>
+          <a:lstStyle/>
+          <a:p>
+            <a:pPr>
+              <a:spcAft>
+                <a:spcPts val="500"/>
+              </a:spcAft>
+            </a:pPr>
+            <a:r>
+              <a:rPr sz="1400" b="0">
+                <a:solidFill>
+                  <a:srgbClr val="1A1A2E"/>
+                </a:solidFill>
+                <a:latin typeface="Calibri"/>
+              </a:rPr>
+              <a:t>ρ (raw shape agreement) fits NOTHING — no map, no rows-per-dimension floor. Width and hub membership are irrelevant to it, so the two falsifications stand on matched pooling alone.</a:t>
+            </a:r>
+          </a:p>
+          <a:p>
+            <a:pPr>
+              <a:spcAft>
+                <a:spcPts val="500"/>
+              </a:spcAft>
+            </a:pPr>
+            <a:r>
+              <a:rPr sz="1400" b="0">
+                <a:solidFill>
+                  <a:srgbClr val="1A1A2E"/>
+                </a:solidFill>
+                <a:latin typeface="Calibri"/>
+              </a:rPr>
+              <a:t/>
+            </a:r>
+          </a:p>
+          <a:p>
+            <a:pPr>
+              <a:spcAft>
+                <a:spcPts val="500"/>
+              </a:spcAft>
+            </a:pPr>
+            <a:r>
+              <a:rPr sz="1400" b="1">
+                <a:solidFill>
+                  <a:srgbClr val="1E2761"/>
+                </a:solidFill>
+                <a:latin typeface="Calibri"/>
+              </a:rPr>
+              <a:t>Transfer for the large models is INCONCLUSIVE by construction:</a:t>
+            </a:r>
+          </a:p>
+          <a:p>
+            <a:pPr>
+              <a:spcAft>
+                <a:spcPts val="500"/>
+              </a:spcAft>
+            </a:pPr>
+            <a:r>
+              <a:rPr sz="1400" b="0">
+                <a:solidFill>
+                  <a:srgbClr val="1A1A2E"/>
+                </a:solidFill>
+                <a:latin typeface="Calibri"/>
+              </a:rPr>
+              <a:t>•  DINOv2-giant at 2.8 rows/dim — its 100.0% is degeneracy (the denominator collapses), not excellence.</a:t>
+            </a:r>
+          </a:p>
+          <a:p>
+            <a:pPr>
+              <a:spcAft>
+                <a:spcPts val="500"/>
+              </a:spcAft>
+            </a:pPr>
+            <a:r>
+              <a:rPr sz="1400" b="0">
+                <a:solidFill>
+                  <a:srgbClr val="1A1A2E"/>
+                </a:solidFill>
+                <a:latin typeface="Calibri"/>
+              </a:rPr>
+              <a:t>•  Qwen-4B at 3.3 rows/dim — underpowered; flagged, not interpreted.</a:t>
+            </a:r>
+          </a:p>
+          <a:p>
+            <a:pPr>
+              <a:spcAft>
+                <a:spcPts val="500"/>
+              </a:spcAft>
+            </a:pPr>
+            <a:r>
+              <a:rPr sz="1400" b="0">
+                <a:solidFill>
+                  <a:srgbClr val="1A1A2E"/>
+                </a:solidFill>
+                <a:latin typeface="Calibri"/>
+              </a:rPr>
+              <a:t>•  ConvNeXt control 101.2% vs published 96.7% — tested: McNemar p = 0.668, CI contains 100% → NOISE.</a:t>
+            </a:r>
+          </a:p>
+          <a:p>
+            <a:pPr>
+              <a:spcAft>
+                <a:spcPts val="500"/>
+              </a:spcAft>
+            </a:pPr>
+            <a:r>
+              <a:rPr sz="1400" b="0">
+                <a:solidFill>
+                  <a:srgbClr val="1A1A2E"/>
+                </a:solidFill>
+                <a:latin typeface="Calibri"/>
+              </a:rPr>
+              <a:t/>
+            </a:r>
+          </a:p>
+          <a:p>
+            <a:pPr>
+              <a:spcAft>
+                <a:spcPts val="500"/>
+              </a:spcAft>
+            </a:pPr>
+            <a:r>
+              <a:rPr sz="1400" b="0">
+                <a:solidFill>
+                  <a:srgbClr val="5A6472"/>
+                </a:solidFill>
+                <a:latin typeface="Calibri"/>
+              </a:rPr>
+              <a:t>Two catches, both recorded. An earlier giant run used cls-only pooling (ρ 0.238), confounding capacity with pooling; re-run at cls+patch gives 0.339 and the drop persists. And giant cannot join the hub as a member — 10,752 dims over 8,533 rows is γ = 1.26, rank-deficient — so it stays a source, which keeps its result a genuine held-out test.</a:t>
+            </a:r>
+          </a:p>
+        </p:txBody>
+      </p:sp>
+    </p:spTree>
+  </p:cSld>
+  <p:clrMapOvr>
+    <a:masterClrMapping/>
+  </p:clrMapOvr>
+</p:sld>
+</file>
+
+<file path=ppt/slides/slide15.xml><?xml version="1.0" encoding="utf-8"?>
 <p:sld xmlns:a="http://schemas.openxmlformats.org/drawingml/2006/main" xmlns:r="http://schemas.openxmlformats.org/officeDocument/2006/relationships" xmlns:p="http://schemas.openxmlformats.org/presentationml/2006/main">
   <p:cSld name="Slide 13">
     <p:bg>
@@ -5476,7 +6027,7 @@
 </p:sld>
 </file>
 
-<file path=ppt/slides/slide14.xml><?xml version="1.0" encoding="utf-8"?>
+<file path=ppt/slides/slide16.xml><?xml version="1.0" encoding="utf-8"?>
 <p:sld xmlns:a="http://schemas.openxmlformats.org/drawingml/2006/main" xmlns:r="http://schemas.openxmlformats.org/officeDocument/2006/relationships" xmlns:p="http://schemas.openxmlformats.org/presentationml/2006/main">
   <p:cSld name="Slide 14">
     <p:bg>
@@ -5660,7 +6211,7 @@
                 <a:ea typeface="Calibri" pitchFamily="34" charset="-122"/>
                 <a:cs typeface="Calibri" pitchFamily="34" charset="-120"/>
               </a:rPr>
-              <a:t>TEN explanations tested and killed on pre-registered criteria — local-structure loss, spectral amplification, four cliff statistics, conditioning — including one of our own tests that was itself wrong, and is recorded as such.</a:t>
+              <a:t>SEVEN accounts falsified and the eighth — a rank wall — confirmed, all on pre-registered criteria — local-structure loss, spectral amplification, four cliff statistics, conditioning — including one of our own tests that was itself wrong, and is recorded as such.</a:t>
             </a:r>
             <a:endParaRPr lang="en-US" sz="1200" dirty="0"/>
           </a:p>
@@ -5755,7 +6306,7 @@
 </p:sld>
 </file>
 
-<file path=ppt/slides/slide15.xml><?xml version="1.0" encoding="utf-8"?>
+<file path=ppt/slides/slide17.xml><?xml version="1.0" encoding="utf-8"?>
 <p:sld xmlns:a="http://schemas.openxmlformats.org/drawingml/2006/main" xmlns:r="http://schemas.openxmlformats.org/officeDocument/2006/relationships" xmlns:p="http://schemas.openxmlformats.org/presentationml/2006/main">
   <p:cSld name="Slide 15">
     <p:bg>
@@ -5878,6 +6429,10 @@
           </a:solidFill>
           <a:ln/>
         </p:spPr>
+        <p:txBody>
+          <a:bodyPr/>
+          <a:p/>
+        </p:txBody>
       </p:sp>
       <p:sp>
         <p:nvSpPr>
@@ -5978,6 +6533,10 @@
           </a:solidFill>
           <a:ln/>
         </p:spPr>
+        <p:txBody>
+          <a:bodyPr/>
+          <a:p/>
+        </p:txBody>
       </p:sp>
       <p:sp>
         <p:nvSpPr>
@@ -6078,6 +6637,10 @@
           </a:solidFill>
           <a:ln/>
         </p:spPr>
+        <p:txBody>
+          <a:bodyPr/>
+          <a:p/>
+        </p:txBody>
       </p:sp>
       <p:sp>
         <p:nvSpPr>
@@ -6178,6 +6741,10 @@
           </a:solidFill>
           <a:ln/>
         </p:spPr>
+        <p:txBody>
+          <a:bodyPr/>
+          <a:p/>
+        </p:txBody>
       </p:sp>
       <p:sp>
         <p:nvSpPr>
@@ -6278,6 +6845,10 @@
           </a:solidFill>
           <a:ln/>
         </p:spPr>
+        <p:txBody>
+          <a:bodyPr/>
+          <a:p/>
+        </p:txBody>
       </p:sp>
       <p:sp>
         <p:nvSpPr>
@@ -6378,6 +6949,10 @@
           </a:solidFill>
           <a:ln/>
         </p:spPr>
+        <p:txBody>
+          <a:bodyPr/>
+          <a:p/>
+        </p:txBody>
       </p:sp>
       <p:sp>
         <p:nvSpPr>
@@ -6465,7 +7040,7 @@
 </p:sld>
 </file>
 
-<file path=ppt/slides/slide16.xml><?xml version="1.0" encoding="utf-8"?>
+<file path=ppt/slides/slide18.xml><?xml version="1.0" encoding="utf-8"?>
 <p:sld xmlns:a="http://schemas.openxmlformats.org/drawingml/2006/main" xmlns:r="http://schemas.openxmlformats.org/officeDocument/2006/relationships" xmlns:p="http://schemas.openxmlformats.org/presentationml/2006/main">
   <p:cSld name="Slide 16">
     <p:bg>
@@ -9016,7 +9591,7 @@
 </p:sld>
 </file>
 
-<file path=ppt/slides/slide17.xml><?xml version="1.0" encoding="utf-8"?>
+<file path=ppt/slides/slide19.xml><?xml version="1.0" encoding="utf-8"?>
 <p:sld xmlns:a="http://schemas.openxmlformats.org/drawingml/2006/main" xmlns:r="http://schemas.openxmlformats.org/officeDocument/2006/relationships" xmlns:p="http://schemas.openxmlformats.org/presentationml/2006/main">
   <p:cSld name="Slide 17">
     <p:bg>
@@ -10776,6 +11351,10 @@
           </a:solidFill>
           <a:ln/>
         </p:spPr>
+        <p:txBody>
+          <a:bodyPr/>
+          <a:p/>
+        </p:txBody>
       </p:sp>
       <p:sp>
         <p:nvSpPr>
@@ -10905,7 +11484,399 @@
 </p:sld>
 </file>
 
-<file path=ppt/slides/slide18.xml><?xml version="1.0" encoding="utf-8"?>
+<file path=ppt/slides/slide2.xml><?xml version="1.0" encoding="utf-8"?>
+<p:sld xmlns:a="http://schemas.openxmlformats.org/drawingml/2006/main" xmlns:r="http://schemas.openxmlformats.org/officeDocument/2006/relationships" xmlns:p="http://schemas.openxmlformats.org/presentationml/2006/main">
+  <p:cSld name="Slide 2">
+    <p:bg>
+      <p:bgPr>
+        <a:solidFill>
+          <a:srgbClr val="FFFFFF"/>
+        </a:solidFill>
+      </p:bgPr>
+    </p:bg>
+    <p:spTree>
+      <p:nvGrpSpPr>
+        <p:cNvPr id="1" name=""/>
+        <p:cNvGrpSpPr/>
+        <p:nvPr/>
+      </p:nvGrpSpPr>
+      <p:grpSpPr>
+        <a:xfrm>
+          <a:off x="0" y="0"/>
+          <a:ext cx="0" cy="0"/>
+          <a:chOff x="0" y="0"/>
+          <a:chExt cx="0" cy="0"/>
+        </a:xfrm>
+      </p:grpSpPr>
+      <p:sp>
+        <p:nvSpPr>
+          <p:cNvPr id="2" name="Text 0"/>
+          <p:cNvSpPr txBox="1"/>
+          <p:nvPr/>
+        </p:nvSpPr>
+        <p:spPr>
+          <a:xfrm>
+            <a:off x="502920" y="256032"/>
+            <a:ext cx="11155680" cy="274320"/>
+          </a:xfrm>
+          <a:prstGeom prst="rect">
+            <a:avLst/>
+          </a:prstGeom>
+          <a:noFill/>
+          <a:ln/>
+        </p:spPr>
+        <p:txBody>
+          <a:bodyPr wrap="square" lIns="0" tIns="0" rIns="0" bIns="0" rtlCol="0" anchor="ctr"/>
+          <a:lstStyle/>
+          <a:p>
+            <a:pPr indent="0" marL="0">
+              <a:buNone/>
+            </a:pPr>
+            <a:r>
+              <a:rPr lang="en-US" sz="1100" spc="200" kern="0" dirty="0">
+                <a:solidFill>
+                  <a:srgbClr val="5A6472"/>
+                </a:solidFill>
+                <a:latin typeface="Calibri" pitchFamily="34" charset="0"/>
+                <a:ea typeface="Calibri" pitchFamily="34" charset="-122"/>
+                <a:cs typeface="Calibri" pitchFamily="34" charset="-120"/>
+              </a:rPr>
+              <a:t>MOTIVATION</a:t>
+            </a:r>
+            <a:endParaRPr lang="en-US" sz="1100" dirty="0"/>
+          </a:p>
+        </p:txBody>
+      </p:sp>
+      <p:sp>
+        <p:nvSpPr>
+          <p:cNvPr id="3" name="Text 1"/>
+          <p:cNvSpPr txBox="1"/>
+          <p:nvPr/>
+        </p:nvSpPr>
+        <p:spPr>
+          <a:xfrm>
+            <a:off x="502920" y="502920"/>
+            <a:ext cx="11155680" cy="685800"/>
+          </a:xfrm>
+          <a:prstGeom prst="rect">
+            <a:avLst/>
+          </a:prstGeom>
+          <a:noFill/>
+          <a:ln/>
+        </p:spPr>
+        <p:txBody>
+          <a:bodyPr wrap="square" lIns="0" tIns="0" rIns="0" bIns="0" rtlCol="0" anchor="ctr"/>
+          <a:lstStyle/>
+          <a:p>
+            <a:pPr indent="0" marL="0">
+              <a:buNone/>
+            </a:pPr>
+            <a:r>
+              <a:rPr lang="en-US" sz="3000" b="1" dirty="0">
+                <a:solidFill>
+                  <a:srgbClr val="1E2761"/>
+                </a:solidFill>
+                <a:latin typeface="Cambria" pitchFamily="34" charset="0"/>
+                <a:ea typeface="Cambria" pitchFamily="34" charset="-122"/>
+                <a:cs typeface="Cambria" pitchFamily="34" charset="-120"/>
+              </a:rPr>
+              <a:t>Why this project</a:t>
+            </a:r>
+            <a:endParaRPr lang="en-US" sz="3000" dirty="0"/>
+          </a:p>
+        </p:txBody>
+      </p:sp>
+      <p:sp>
+        <p:nvSpPr>
+          <p:cNvPr id="4" name="Text 2"/>
+          <p:cNvSpPr txBox="1"/>
+          <p:nvPr/>
+        </p:nvSpPr>
+        <p:spPr>
+          <a:xfrm>
+            <a:off x="502920" y="1417320"/>
+            <a:ext cx="6400800" cy="4754880"/>
+          </a:xfrm>
+          <a:prstGeom prst="rect">
+            <a:avLst/>
+          </a:prstGeom>
+          <a:noFill/>
+          <a:ln/>
+        </p:spPr>
+        <p:txBody>
+          <a:bodyPr wrap="square" lIns="0" tIns="0" rIns="0" bIns="0" rtlCol="0" anchor="t"/>
+          <a:lstStyle/>
+          <a:p>
+            <a:pPr marL="152400" indent="-152400">
+              <a:spcAft>
+                <a:spcPts val="800"/>
+              </a:spcAft>
+              <a:buSzPct val="100000"/>
+              <a:buChar char="•"/>
+            </a:pPr>
+            <a:r>
+              <a:rPr lang="en-US" sz="1450" dirty="0">
+                <a:solidFill>
+                  <a:srgbClr val="1A1A2E"/>
+                </a:solidFill>
+                <a:latin typeface="Calibri" pitchFamily="34" charset="0"/>
+                <a:ea typeface="Calibri" pitchFamily="34" charset="-122"/>
+                <a:cs typeface="Calibri" pitchFamily="34" charset="-120"/>
+              </a:rPr>
+              <a:t>What fascinates me is what happens behind the scenes of a model — not the demo, the mechanism.</a:t>
+            </a:r>
+            <a:endParaRPr lang="en-US" sz="1450" dirty="0"/>
+          </a:p>
+          <a:p>
+            <a:pPr marL="152400" indent="-152400">
+              <a:spcAft>
+                <a:spcPts val="800"/>
+              </a:spcAft>
+              <a:buSzPct val="100000"/>
+              <a:buChar char="•"/>
+            </a:pPr>
+            <a:r>
+              <a:rPr lang="en-US" sz="1450" dirty="0">
+                <a:solidFill>
+                  <a:srgbClr val="1A1A2E"/>
+                </a:solidFill>
+                <a:latin typeface="Calibri" pitchFamily="34" charset="0"/>
+                <a:ea typeface="Calibri" pitchFamily="34" charset="-122"/>
+                <a:cs typeface="Calibri" pitchFamily="34" charset="-120"/>
+              </a:rPr>
+              <a:t>My background is hybrid — databases and vision, engineering and ‘spirit and matter’. In databases, correlations between features are explicit: a schema, a join, a key. In vision they are implicit — similar in kind, different in form.</a:t>
+            </a:r>
+            <a:endParaRPr lang="en-US" sz="1450" dirty="0"/>
+          </a:p>
+          <a:p>
+            <a:pPr marL="152400" indent="-152400">
+              <a:spcAft>
+                <a:spcPts val="800"/>
+              </a:spcAft>
+              <a:buSzPct val="100000"/>
+              <a:buChar char="•"/>
+            </a:pPr>
+            <a:r>
+              <a:rPr lang="en-US" sz="1450" dirty="0">
+                <a:solidFill>
+                  <a:srgbClr val="1A1A2E"/>
+                </a:solidFill>
+                <a:latin typeface="Calibri" pitchFamily="34" charset="0"/>
+                <a:ea typeface="Calibri" pitchFamily="34" charset="-122"/>
+                <a:cs typeface="Calibri" pitchFamily="34" charset="-120"/>
+              </a:rPr>
+              <a:t>Training itself pulled me in: weights, hyper-parameters, attention, NLP — a world of algorithmics, networks and prediction whose real product is discovered regularity in data.</a:t>
+            </a:r>
+            <a:endParaRPr lang="en-US" sz="1450" dirty="0"/>
+          </a:p>
+          <a:p>
+            <a:pPr marL="152400" indent="-152400">
+              <a:spcAft>
+                <a:spcPts val="800"/>
+              </a:spcAft>
+              <a:buSzPct val="100000"/>
+              <a:buChar char="•"/>
+            </a:pPr>
+            <a:r>
+              <a:rPr lang="en-US" sz="1450" dirty="0">
+                <a:solidFill>
+                  <a:srgbClr val="1A1A2E"/>
+                </a:solidFill>
+                <a:latin typeface="Calibri" pitchFamily="34" charset="0"/>
+                <a:ea typeface="Calibri" pitchFamily="34" charset="-122"/>
+                <a:cs typeface="Calibri" pitchFamily="34" charset="-120"/>
+              </a:rPr>
+              <a:t>The question that stuck: when two systems each discover regularity separately — do they discover the same one?</a:t>
+            </a:r>
+            <a:endParaRPr lang="en-US" sz="1450" dirty="0"/>
+          </a:p>
+        </p:txBody>
+      </p:sp>
+      <p:sp>
+        <p:nvSpPr>
+          <p:cNvPr id="5" name="Shape 3"/>
+          <p:cNvSpPr/>
+          <p:nvPr/>
+        </p:nvSpPr>
+        <p:spPr>
+          <a:xfrm>
+            <a:off x="7315200" y="1554480"/>
+            <a:ext cx="4297680" cy="4206240"/>
+          </a:xfrm>
+          <a:prstGeom prst="roundRect">
+            <a:avLst>
+              <a:gd name="adj" fmla="val 1739"/>
+            </a:avLst>
+          </a:prstGeom>
+          <a:solidFill>
+            <a:srgbClr val="F2F5FB"/>
+          </a:solidFill>
+          <a:ln/>
+        </p:spPr>
+        <p:txBody>
+          <a:bodyPr/>
+          <a:p/>
+        </p:txBody>
+      </p:sp>
+      <p:sp>
+        <p:nvSpPr>
+          <p:cNvPr id="6" name="Text 4"/>
+          <p:cNvSpPr txBox="1"/>
+          <p:nvPr/>
+        </p:nvSpPr>
+        <p:spPr>
+          <a:xfrm>
+            <a:off x="7635240" y="1828800"/>
+            <a:ext cx="3657600" cy="365760"/>
+          </a:xfrm>
+          <a:prstGeom prst="rect">
+            <a:avLst/>
+          </a:prstGeom>
+          <a:noFill/>
+          <a:ln/>
+        </p:spPr>
+        <p:txBody>
+          <a:bodyPr wrap="square" lIns="0" tIns="0" rIns="0" bIns="0" rtlCol="0" anchor="ctr"/>
+          <a:lstStyle/>
+          <a:p>
+            <a:pPr indent="0" marL="0">
+              <a:buNone/>
+            </a:pPr>
+            <a:r>
+              <a:rPr lang="en-US" sz="1500" b="1" dirty="0">
+                <a:solidFill>
+                  <a:srgbClr val="1E2761"/>
+                </a:solidFill>
+                <a:latin typeface="Cambria" pitchFamily="34" charset="0"/>
+                <a:ea typeface="Cambria" pitchFamily="34" charset="-122"/>
+                <a:cs typeface="Cambria" pitchFamily="34" charset="-120"/>
+              </a:rPr>
+              <a:t>Two worlds, one habit</a:t>
+            </a:r>
+            <a:endParaRPr lang="en-US" sz="1500" dirty="0"/>
+          </a:p>
+        </p:txBody>
+      </p:sp>
+      <p:sp>
+        <p:nvSpPr>
+          <p:cNvPr id="7" name="Text 5"/>
+          <p:cNvSpPr txBox="1"/>
+          <p:nvPr/>
+        </p:nvSpPr>
+        <p:spPr>
+          <a:xfrm>
+            <a:off x="7635240" y="2240280"/>
+            <a:ext cx="3703320" cy="3291840"/>
+          </a:xfrm>
+          <a:prstGeom prst="rect">
+            <a:avLst/>
+          </a:prstGeom>
+          <a:noFill/>
+          <a:ln/>
+        </p:spPr>
+        <p:txBody>
+          <a:bodyPr wrap="square" lIns="0" tIns="0" rIns="0" bIns="0" rtlCol="0" anchor="t"/>
+          <a:lstStyle/>
+          <a:p>
+            <a:pPr indent="0" marL="0">
+              <a:buNone/>
+            </a:pPr>
+            <a:r>
+              <a:rPr lang="en-US" sz="1250" b="1" dirty="0">
+                <a:solidFill>
+                  <a:srgbClr val="1A1A2E"/>
+                </a:solidFill>
+                <a:latin typeface="Calibri" pitchFamily="34" charset="0"/>
+                <a:ea typeface="Calibri" pitchFamily="34" charset="-122"/>
+                <a:cs typeface="Calibri" pitchFamily="34" charset="-120"/>
+              </a:rPr>
+              <a:t>Database features:  </a:t>
+            </a:r>
+            <a:pPr indent="0" marL="0">
+              <a:buNone/>
+            </a:pPr>
+            <a:r>
+              <a:rPr lang="en-US" sz="1250" dirty="0">
+                <a:solidFill>
+                  <a:srgbClr val="1A1A2E"/>
+                </a:solidFill>
+                <a:latin typeface="Calibri" pitchFamily="34" charset="0"/>
+                <a:ea typeface="Calibri" pitchFamily="34" charset="-122"/>
+                <a:cs typeface="Calibri" pitchFamily="34" charset="-120"/>
+              </a:rPr>
+              <a:t>price ↔ demand, age ↔ churn — correlation you can name.
+</a:t>
+            </a:r>
+            <a:pPr indent="0" marL="0">
+              <a:buNone/>
+            </a:pPr>
+            <a:r>
+              <a:rPr lang="en-US" sz="1250" b="1" dirty="0">
+                <a:solidFill>
+                  <a:srgbClr val="1A1A2E"/>
+                </a:solidFill>
+                <a:latin typeface="Calibri" pitchFamily="34" charset="0"/>
+                <a:ea typeface="Calibri" pitchFamily="34" charset="-122"/>
+                <a:cs typeface="Calibri" pitchFamily="34" charset="-120"/>
+              </a:rPr>
+              <a:t>Vision features:  </a:t>
+            </a:r>
+            <a:pPr indent="0" marL="0">
+              <a:buNone/>
+            </a:pPr>
+            <a:r>
+              <a:rPr lang="en-US" sz="1250" dirty="0">
+                <a:solidFill>
+                  <a:srgbClr val="1A1A2E"/>
+                </a:solidFill>
+                <a:latin typeface="Calibri" pitchFamily="34" charset="0"/>
+                <a:ea typeface="Calibri" pitchFamily="34" charset="-122"/>
+                <a:cs typeface="Calibri" pitchFamily="34" charset="-120"/>
+              </a:rPr>
+              <a:t>edge ↔ texture ↔ ‘cat-ness’ — correlation nobody wrote down, learned from pixels alone.
+</a:t>
+            </a:r>
+            <a:pPr indent="0" marL="0">
+              <a:buNone/>
+            </a:pPr>
+            <a:r>
+              <a:rPr lang="en-US" sz="1250" i="1" dirty="0">
+                <a:solidFill>
+                  <a:srgbClr val="1A1A2E"/>
+                </a:solidFill>
+                <a:latin typeface="Calibri" pitchFamily="34" charset="0"/>
+                <a:ea typeface="Calibri" pitchFamily="34" charset="-122"/>
+                <a:cs typeface="Calibri" pitchFamily="34" charset="-120"/>
+              </a:rPr>
+              <a:t>Similar, but different — </a:t>
+            </a:r>
+            <a:pPr indent="0" marL="0">
+              <a:buNone/>
+            </a:pPr>
+            <a:r>
+              <a:rPr lang="en-US" sz="1250" dirty="0">
+                <a:solidFill>
+                  <a:srgbClr val="1A1A2E"/>
+                </a:solidFill>
+                <a:latin typeface="Calibri" pitchFamily="34" charset="0"/>
+                <a:ea typeface="Calibri" pitchFamily="34" charset="-122"/>
+                <a:cs typeface="Calibri" pitchFamily="34" charset="-120"/>
+              </a:rPr>
+              <a:t>and both are ultimately geometry over data.</a:t>
+            </a:r>
+            <a:endParaRPr lang="en-US" sz="1250" dirty="0"/>
+          </a:p>
+        </p:txBody>
+      </p:sp>
+    </p:spTree>
+  </p:cSld>
+  <p:clrMapOvr>
+    <a:masterClrMapping/>
+  </p:clrMapOvr>
+</p:sld>
+</file>
+
+<file path=ppt/slides/slide20.xml><?xml version="1.0" encoding="utf-8"?>
 <p:sld xmlns:a="http://schemas.openxmlformats.org/drawingml/2006/main" xmlns:r="http://schemas.openxmlformats.org/officeDocument/2006/relationships" xmlns:p="http://schemas.openxmlformats.org/presentationml/2006/main">
   <p:cSld name="Slide 18">
     <p:bg>
@@ -11308,7 +12279,7 @@
 </p:sld>
 </file>
 
-<file path=ppt/slides/slide19.xml><?xml version="1.0" encoding="utf-8"?>
+<file path=ppt/slides/slide21.xml><?xml version="1.0" encoding="utf-8"?>
 <p:sld xmlns:a="http://schemas.openxmlformats.org/drawingml/2006/main" xmlns:r="http://schemas.openxmlformats.org/officeDocument/2006/relationships" xmlns:p="http://schemas.openxmlformats.org/presentationml/2006/main">
   <p:cSld name="Slide 19">
     <p:bg>
@@ -12640,395 +13611,7 @@
 </p:sld>
 </file>
 
-<file path=ppt/slides/slide2.xml><?xml version="1.0" encoding="utf-8"?>
-<p:sld xmlns:a="http://schemas.openxmlformats.org/drawingml/2006/main" xmlns:r="http://schemas.openxmlformats.org/officeDocument/2006/relationships" xmlns:p="http://schemas.openxmlformats.org/presentationml/2006/main">
-  <p:cSld name="Slide 2">
-    <p:bg>
-      <p:bgPr>
-        <a:solidFill>
-          <a:srgbClr val="FFFFFF"/>
-        </a:solidFill>
-      </p:bgPr>
-    </p:bg>
-    <p:spTree>
-      <p:nvGrpSpPr>
-        <p:cNvPr id="1" name=""/>
-        <p:cNvGrpSpPr/>
-        <p:nvPr/>
-      </p:nvGrpSpPr>
-      <p:grpSpPr>
-        <a:xfrm>
-          <a:off x="0" y="0"/>
-          <a:ext cx="0" cy="0"/>
-          <a:chOff x="0" y="0"/>
-          <a:chExt cx="0" cy="0"/>
-        </a:xfrm>
-      </p:grpSpPr>
-      <p:sp>
-        <p:nvSpPr>
-          <p:cNvPr id="2" name="Text 0"/>
-          <p:cNvSpPr txBox="1"/>
-          <p:nvPr/>
-        </p:nvSpPr>
-        <p:spPr>
-          <a:xfrm>
-            <a:off x="502920" y="256032"/>
-            <a:ext cx="11155680" cy="274320"/>
-          </a:xfrm>
-          <a:prstGeom prst="rect">
-            <a:avLst/>
-          </a:prstGeom>
-          <a:noFill/>
-          <a:ln/>
-        </p:spPr>
-        <p:txBody>
-          <a:bodyPr wrap="square" lIns="0" tIns="0" rIns="0" bIns="0" rtlCol="0" anchor="ctr"/>
-          <a:lstStyle/>
-          <a:p>
-            <a:pPr indent="0" marL="0">
-              <a:buNone/>
-            </a:pPr>
-            <a:r>
-              <a:rPr lang="en-US" sz="1100" spc="200" kern="0" dirty="0">
-                <a:solidFill>
-                  <a:srgbClr val="5A6472"/>
-                </a:solidFill>
-                <a:latin typeface="Calibri" pitchFamily="34" charset="0"/>
-                <a:ea typeface="Calibri" pitchFamily="34" charset="-122"/>
-                <a:cs typeface="Calibri" pitchFamily="34" charset="-120"/>
-              </a:rPr>
-              <a:t>MOTIVATION</a:t>
-            </a:r>
-            <a:endParaRPr lang="en-US" sz="1100" dirty="0"/>
-          </a:p>
-        </p:txBody>
-      </p:sp>
-      <p:sp>
-        <p:nvSpPr>
-          <p:cNvPr id="3" name="Text 1"/>
-          <p:cNvSpPr txBox="1"/>
-          <p:nvPr/>
-        </p:nvSpPr>
-        <p:spPr>
-          <a:xfrm>
-            <a:off x="502920" y="502920"/>
-            <a:ext cx="11155680" cy="685800"/>
-          </a:xfrm>
-          <a:prstGeom prst="rect">
-            <a:avLst/>
-          </a:prstGeom>
-          <a:noFill/>
-          <a:ln/>
-        </p:spPr>
-        <p:txBody>
-          <a:bodyPr wrap="square" lIns="0" tIns="0" rIns="0" bIns="0" rtlCol="0" anchor="ctr"/>
-          <a:lstStyle/>
-          <a:p>
-            <a:pPr indent="0" marL="0">
-              <a:buNone/>
-            </a:pPr>
-            <a:r>
-              <a:rPr lang="en-US" sz="3000" b="1" dirty="0">
-                <a:solidFill>
-                  <a:srgbClr val="1E2761"/>
-                </a:solidFill>
-                <a:latin typeface="Cambria" pitchFamily="34" charset="0"/>
-                <a:ea typeface="Cambria" pitchFamily="34" charset="-122"/>
-                <a:cs typeface="Cambria" pitchFamily="34" charset="-120"/>
-              </a:rPr>
-              <a:t>Why this project</a:t>
-            </a:r>
-            <a:endParaRPr lang="en-US" sz="3000" dirty="0"/>
-          </a:p>
-        </p:txBody>
-      </p:sp>
-      <p:sp>
-        <p:nvSpPr>
-          <p:cNvPr id="4" name="Text 2"/>
-          <p:cNvSpPr txBox="1"/>
-          <p:nvPr/>
-        </p:nvSpPr>
-        <p:spPr>
-          <a:xfrm>
-            <a:off x="502920" y="1417320"/>
-            <a:ext cx="6400800" cy="4754880"/>
-          </a:xfrm>
-          <a:prstGeom prst="rect">
-            <a:avLst/>
-          </a:prstGeom>
-          <a:noFill/>
-          <a:ln/>
-        </p:spPr>
-        <p:txBody>
-          <a:bodyPr wrap="square" lIns="0" tIns="0" rIns="0" bIns="0" rtlCol="0" anchor="t"/>
-          <a:lstStyle/>
-          <a:p>
-            <a:pPr marL="152400" indent="-152400">
-              <a:spcAft>
-                <a:spcPts val="800"/>
-              </a:spcAft>
-              <a:buSzPct val="100000"/>
-              <a:buChar char="•"/>
-            </a:pPr>
-            <a:r>
-              <a:rPr lang="en-US" sz="1450" dirty="0">
-                <a:solidFill>
-                  <a:srgbClr val="1A1A2E"/>
-                </a:solidFill>
-                <a:latin typeface="Calibri" pitchFamily="34" charset="0"/>
-                <a:ea typeface="Calibri" pitchFamily="34" charset="-122"/>
-                <a:cs typeface="Calibri" pitchFamily="34" charset="-120"/>
-              </a:rPr>
-              <a:t>What fascinates me is what happens behind the scenes of a model — not the demo, the mechanism.</a:t>
-            </a:r>
-            <a:endParaRPr lang="en-US" sz="1450" dirty="0"/>
-          </a:p>
-          <a:p>
-            <a:pPr marL="152400" indent="-152400">
-              <a:spcAft>
-                <a:spcPts val="800"/>
-              </a:spcAft>
-              <a:buSzPct val="100000"/>
-              <a:buChar char="•"/>
-            </a:pPr>
-            <a:r>
-              <a:rPr lang="en-US" sz="1450" dirty="0">
-                <a:solidFill>
-                  <a:srgbClr val="1A1A2E"/>
-                </a:solidFill>
-                <a:latin typeface="Calibri" pitchFamily="34" charset="0"/>
-                <a:ea typeface="Calibri" pitchFamily="34" charset="-122"/>
-                <a:cs typeface="Calibri" pitchFamily="34" charset="-120"/>
-              </a:rPr>
-              <a:t>My background is hybrid — databases and vision, engineering and ‘spirit and matter’. In databases, correlations between features are explicit: a schema, a join, a key. In vision they are implicit — similar in kind, different in form.</a:t>
-            </a:r>
-            <a:endParaRPr lang="en-US" sz="1450" dirty="0"/>
-          </a:p>
-          <a:p>
-            <a:pPr marL="152400" indent="-152400">
-              <a:spcAft>
-                <a:spcPts val="800"/>
-              </a:spcAft>
-              <a:buSzPct val="100000"/>
-              <a:buChar char="•"/>
-            </a:pPr>
-            <a:r>
-              <a:rPr lang="en-US" sz="1450" dirty="0">
-                <a:solidFill>
-                  <a:srgbClr val="1A1A2E"/>
-                </a:solidFill>
-                <a:latin typeface="Calibri" pitchFamily="34" charset="0"/>
-                <a:ea typeface="Calibri" pitchFamily="34" charset="-122"/>
-                <a:cs typeface="Calibri" pitchFamily="34" charset="-120"/>
-              </a:rPr>
-              <a:t>Training itself pulled me in: weights, hyper-parameters, attention, NLP — a world of algorithmics, networks and prediction whose real product is discovered regularity in data.</a:t>
-            </a:r>
-            <a:endParaRPr lang="en-US" sz="1450" dirty="0"/>
-          </a:p>
-          <a:p>
-            <a:pPr marL="152400" indent="-152400">
-              <a:spcAft>
-                <a:spcPts val="800"/>
-              </a:spcAft>
-              <a:buSzPct val="100000"/>
-              <a:buChar char="•"/>
-            </a:pPr>
-            <a:r>
-              <a:rPr lang="en-US" sz="1450" dirty="0">
-                <a:solidFill>
-                  <a:srgbClr val="1A1A2E"/>
-                </a:solidFill>
-                <a:latin typeface="Calibri" pitchFamily="34" charset="0"/>
-                <a:ea typeface="Calibri" pitchFamily="34" charset="-122"/>
-                <a:cs typeface="Calibri" pitchFamily="34" charset="-120"/>
-              </a:rPr>
-              <a:t>The question that stuck: when two systems each discover regularity separately — do they discover the same one?</a:t>
-            </a:r>
-            <a:endParaRPr lang="en-US" sz="1450" dirty="0"/>
-          </a:p>
-        </p:txBody>
-      </p:sp>
-      <p:sp>
-        <p:nvSpPr>
-          <p:cNvPr id="5" name="Shape 3"/>
-          <p:cNvSpPr/>
-          <p:nvPr/>
-        </p:nvSpPr>
-        <p:spPr>
-          <a:xfrm>
-            <a:off x="7315200" y="1554480"/>
-            <a:ext cx="4297680" cy="4206240"/>
-          </a:xfrm>
-          <a:prstGeom prst="roundRect">
-            <a:avLst>
-              <a:gd name="adj" fmla="val 1739"/>
-            </a:avLst>
-          </a:prstGeom>
-          <a:solidFill>
-            <a:srgbClr val="F2F5FB"/>
-          </a:solidFill>
-          <a:ln/>
-        </p:spPr>
-      </p:sp>
-      <p:sp>
-        <p:nvSpPr>
-          <p:cNvPr id="6" name="Text 4"/>
-          <p:cNvSpPr txBox="1"/>
-          <p:nvPr/>
-        </p:nvSpPr>
-        <p:spPr>
-          <a:xfrm>
-            <a:off x="7635240" y="1828800"/>
-            <a:ext cx="3657600" cy="365760"/>
-          </a:xfrm>
-          <a:prstGeom prst="rect">
-            <a:avLst/>
-          </a:prstGeom>
-          <a:noFill/>
-          <a:ln/>
-        </p:spPr>
-        <p:txBody>
-          <a:bodyPr wrap="square" lIns="0" tIns="0" rIns="0" bIns="0" rtlCol="0" anchor="ctr"/>
-          <a:lstStyle/>
-          <a:p>
-            <a:pPr indent="0" marL="0">
-              <a:buNone/>
-            </a:pPr>
-            <a:r>
-              <a:rPr lang="en-US" sz="1500" b="1" dirty="0">
-                <a:solidFill>
-                  <a:srgbClr val="1E2761"/>
-                </a:solidFill>
-                <a:latin typeface="Cambria" pitchFamily="34" charset="0"/>
-                <a:ea typeface="Cambria" pitchFamily="34" charset="-122"/>
-                <a:cs typeface="Cambria" pitchFamily="34" charset="-120"/>
-              </a:rPr>
-              <a:t>Two worlds, one habit</a:t>
-            </a:r>
-            <a:endParaRPr lang="en-US" sz="1500" dirty="0"/>
-          </a:p>
-        </p:txBody>
-      </p:sp>
-      <p:sp>
-        <p:nvSpPr>
-          <p:cNvPr id="7" name="Text 5"/>
-          <p:cNvSpPr txBox="1"/>
-          <p:nvPr/>
-        </p:nvSpPr>
-        <p:spPr>
-          <a:xfrm>
-            <a:off x="7635240" y="2240280"/>
-            <a:ext cx="3703320" cy="3291840"/>
-          </a:xfrm>
-          <a:prstGeom prst="rect">
-            <a:avLst/>
-          </a:prstGeom>
-          <a:noFill/>
-          <a:ln/>
-        </p:spPr>
-        <p:txBody>
-          <a:bodyPr wrap="square" lIns="0" tIns="0" rIns="0" bIns="0" rtlCol="0" anchor="t"/>
-          <a:lstStyle/>
-          <a:p>
-            <a:pPr indent="0" marL="0">
-              <a:buNone/>
-            </a:pPr>
-            <a:r>
-              <a:rPr lang="en-US" sz="1250" b="1" dirty="0">
-                <a:solidFill>
-                  <a:srgbClr val="1A1A2E"/>
-                </a:solidFill>
-                <a:latin typeface="Calibri" pitchFamily="34" charset="0"/>
-                <a:ea typeface="Calibri" pitchFamily="34" charset="-122"/>
-                <a:cs typeface="Calibri" pitchFamily="34" charset="-120"/>
-              </a:rPr>
-              <a:t>Database features:  </a:t>
-            </a:r>
-            <a:pPr indent="0" marL="0">
-              <a:buNone/>
-            </a:pPr>
-            <a:r>
-              <a:rPr lang="en-US" sz="1250" dirty="0">
-                <a:solidFill>
-                  <a:srgbClr val="1A1A2E"/>
-                </a:solidFill>
-                <a:latin typeface="Calibri" pitchFamily="34" charset="0"/>
-                <a:ea typeface="Calibri" pitchFamily="34" charset="-122"/>
-                <a:cs typeface="Calibri" pitchFamily="34" charset="-120"/>
-              </a:rPr>
-              <a:t>price ↔ demand, age ↔ churn — correlation you can name.
-</a:t>
-            </a:r>
-            <a:pPr indent="0" marL="0">
-              <a:buNone/>
-            </a:pPr>
-            <a:r>
-              <a:rPr lang="en-US" sz="1250" b="1" dirty="0">
-                <a:solidFill>
-                  <a:srgbClr val="1A1A2E"/>
-                </a:solidFill>
-                <a:latin typeface="Calibri" pitchFamily="34" charset="0"/>
-                <a:ea typeface="Calibri" pitchFamily="34" charset="-122"/>
-                <a:cs typeface="Calibri" pitchFamily="34" charset="-120"/>
-              </a:rPr>
-              <a:t>Vision features:  </a:t>
-            </a:r>
-            <a:pPr indent="0" marL="0">
-              <a:buNone/>
-            </a:pPr>
-            <a:r>
-              <a:rPr lang="en-US" sz="1250" dirty="0">
-                <a:solidFill>
-                  <a:srgbClr val="1A1A2E"/>
-                </a:solidFill>
-                <a:latin typeface="Calibri" pitchFamily="34" charset="0"/>
-                <a:ea typeface="Calibri" pitchFamily="34" charset="-122"/>
-                <a:cs typeface="Calibri" pitchFamily="34" charset="-120"/>
-              </a:rPr>
-              <a:t>edge ↔ texture ↔ ‘cat-ness’ — correlation nobody wrote down, learned from pixels alone.
-</a:t>
-            </a:r>
-            <a:pPr indent="0" marL="0">
-              <a:buNone/>
-            </a:pPr>
-            <a:r>
-              <a:rPr lang="en-US" sz="1250" i="1" dirty="0">
-                <a:solidFill>
-                  <a:srgbClr val="1A1A2E"/>
-                </a:solidFill>
-                <a:latin typeface="Calibri" pitchFamily="34" charset="0"/>
-                <a:ea typeface="Calibri" pitchFamily="34" charset="-122"/>
-                <a:cs typeface="Calibri" pitchFamily="34" charset="-120"/>
-              </a:rPr>
-              <a:t>Similar, but different — </a:t>
-            </a:r>
-            <a:pPr indent="0" marL="0">
-              <a:buNone/>
-            </a:pPr>
-            <a:r>
-              <a:rPr lang="en-US" sz="1250" dirty="0">
-                <a:solidFill>
-                  <a:srgbClr val="1A1A2E"/>
-                </a:solidFill>
-                <a:latin typeface="Calibri" pitchFamily="34" charset="0"/>
-                <a:ea typeface="Calibri" pitchFamily="34" charset="-122"/>
-                <a:cs typeface="Calibri" pitchFamily="34" charset="-120"/>
-              </a:rPr>
-              <a:t>and both are ultimately geometry over data.</a:t>
-            </a:r>
-            <a:endParaRPr lang="en-US" sz="1250" dirty="0"/>
-          </a:p>
-        </p:txBody>
-      </p:sp>
-    </p:spTree>
-  </p:cSld>
-  <p:clrMapOvr>
-    <a:masterClrMapping/>
-  </p:clrMapOvr>
-</p:sld>
-</file>
-
-<file path=ppt/slides/slide20.xml><?xml version="1.0" encoding="utf-8"?>
+<file path=ppt/slides/slide22.xml><?xml version="1.0" encoding="utf-8"?>
 <p:sld xmlns:a="http://schemas.openxmlformats.org/drawingml/2006/main" xmlns:r="http://schemas.openxmlformats.org/officeDocument/2006/relationships" xmlns:p="http://schemas.openxmlformats.org/presentationml/2006/main">
   <p:cSld name="Slide 20">
     <p:bg>
@@ -13697,6 +14280,10 @@
           </a:solidFill>
           <a:ln/>
         </p:spPr>
+        <p:txBody>
+          <a:bodyPr/>
+          <a:p/>
+        </p:txBody>
       </p:sp>
       <p:sp>
         <p:nvSpPr>
@@ -14863,6 +15450,10 @@
           </a:solidFill>
           <a:ln/>
         </p:spPr>
+        <p:txBody>
+          <a:bodyPr/>
+          <a:p/>
+        </p:txBody>
       </p:sp>
       <p:sp>
         <p:nvSpPr>
@@ -15231,6 +15822,10 @@
           </a:solidFill>
           <a:ln/>
         </p:spPr>
+        <p:txBody>
+          <a:bodyPr/>
+          <a:p/>
+        </p:txBody>
       </p:sp>
       <p:sp>
         <p:nvSpPr>
@@ -15350,6 +15945,10 @@
             <a:tailEnd type="triangle"/>
           </a:ln>
         </p:spPr>
+        <p:txBody>
+          <a:bodyPr/>
+          <a:p/>
+        </p:txBody>
       </p:sp>
       <p:sp>
         <p:nvSpPr>
@@ -15372,6 +15971,10 @@
           </a:solidFill>
           <a:ln/>
         </p:spPr>
+        <p:txBody>
+          <a:bodyPr/>
+          <a:p/>
+        </p:txBody>
       </p:sp>
       <p:sp>
         <p:nvSpPr>
@@ -15508,6 +16111,10 @@
             <a:tailEnd type="triangle"/>
           </a:ln>
         </p:spPr>
+        <p:txBody>
+          <a:bodyPr/>
+          <a:p/>
+        </p:txBody>
       </p:sp>
       <p:sp>
         <p:nvSpPr>
@@ -15530,6 +16137,10 @@
           </a:solidFill>
           <a:ln/>
         </p:spPr>
+        <p:txBody>
+          <a:bodyPr/>
+          <a:p/>
+        </p:txBody>
       </p:sp>
       <p:sp>
         <p:nvSpPr>
@@ -15649,6 +16260,10 @@
             <a:tailEnd type="triangle"/>
           </a:ln>
         </p:spPr>
+        <p:txBody>
+          <a:bodyPr/>
+          <a:p/>
+        </p:txBody>
       </p:sp>
       <p:sp>
         <p:nvSpPr>
@@ -15671,6 +16286,10 @@
           </a:solidFill>
           <a:ln/>
         </p:spPr>
+        <p:txBody>
+          <a:bodyPr/>
+          <a:p/>
+        </p:txBody>
       </p:sp>
       <p:sp>
         <p:nvSpPr>
@@ -16610,6 +17229,10 @@
             <a:prstDash val="solid"/>
           </a:ln>
         </p:spPr>
+        <p:txBody>
+          <a:bodyPr/>
+          <a:p/>
+        </p:txBody>
       </p:sp>
       <p:sp>
         <p:nvSpPr>

</xml_diff>